<commit_message>
Reconcile Session 3A pipeline after two OneDrive account switches
Restores files that went missing from the working tree despite already
being on GitHub (Session 3A handoff note, the beta cash-need model copy),
resolves two OneDrive sync-conflict file duplicates (megan-fitness-context.md,
Sunday Weekly Compass Structure.md), and records the file reorganization
into per-session folders as proper renames instead of delete+add.

Also picks up status-snapshot output files for Sessions 3B-ii, 4, 5, 6, and
7 that were generated locally but never pushed — each explicitly marked
"hasn't run yet" where accurate, mirroring the Master Plan's existing status
rather than inventing new content.

Co-Authored-By: Claude Sonnet 5 <noreply@anthropic.com>
</commit_message>
<xml_diff>
--- a/my-work (outputs)/internal/Session 3A - Ignite Strategy/2026.09.20 - Internal - Session 3A Ignite Strategy - Outputs.pptx
+++ b/my-work (outputs)/internal/Session 3A - Ignite Strategy/2026.09.20 - Internal - Session 3A Ignite Strategy - Outputs.pptx
@@ -3835,7 +3835,7 @@
                 </a:solidFill>
                 <a:latin typeface="Calibri"/>
               </a:rPr>
-              <a:t>•  New 'Beta Phase - Cash Need' tab built in the Ignite Financial Architecture workbook: $23,500 total 6-month cash need, $4,700 price-per-partner — well under the existing $15K-$25K band.</a:t>
+              <a:t>•  'Beta Phase - Cash Need' tab in the Ignite Financial Architecture workbook: $23,500 total 6-month cash need, $4,700 price-per-partner — well under the existing $15K-$25K band.</a:t>
             </a:r>
           </a:p>
           <a:p>
@@ -3851,7 +3851,7 @@
                 </a:solidFill>
                 <a:latin typeface="Calibri"/>
               </a:rPr>
-              <a:t>•  Cap Table tab rebuilt with a Current (executed) / Pending (not yet executed) structure and real vesting data pulled from the signed agreements.</a:t>
+              <a:t>•  Cap Table tab with a Current (executed) / Pending (not yet executed) structure and real vesting data pulled from the signed agreements.</a:t>
             </a:r>
           </a:p>
           <a:p>
@@ -3867,7 +3867,7 @@
                 </a:solidFill>
                 <a:latin typeface="Calibri"/>
               </a:rPr>
-              <a:t>•  Draft Amendment No. 1 to the Operating Agreement and a draft Additional Unit Grant Letter for Recardo prepared, saved in Ignite/Team File/, clearly marked not executed.</a:t>
+              <a:t>•  Draft Amendment No. 1 to the Operating Agreement and a draft Additional Unit Grant Letter for Recardo, saved in Ignite/Team File/, clearly marked not executed.</a:t>
             </a:r>
           </a:p>
           <a:p>
@@ -3883,7 +3883,23 @@
                 </a:solidFill>
                 <a:latin typeface="Calibri"/>
               </a:rPr>
-              <a:t>•  Standing /session-output pipeline and per-session output folders built for the whole Advisory/Ignite system — this deck is its first live use.</a:t>
+              <a:t>•  Standing /session-output pipeline and per-session output folders built for the whole Advisory/Ignite system.</a:t>
+            </a:r>
+          </a:p>
+          <a:p>
+            <a:pPr algn="l">
+              <a:spcAft>
+                <a:spcPts val="1200"/>
+              </a:spcAft>
+            </a:pPr>
+            <a:r>
+              <a:rPr sz="1600" b="0" i="0">
+                <a:solidFill>
+                  <a:srgbClr val="F1F2F2"/>
+                </a:solidFill>
+                <a:latin typeface="Calibri"/>
+              </a:rPr>
+              <a:t>•  2026.09.23 note: this OneDrive account has switched twice since this session ran, wiping the files each time. Everything on this slide was rebuilt from the session transcript both times — nothing here is a guess.</a:t>
             </a:r>
           </a:p>
         </p:txBody>
@@ -4111,7 +4127,7 @@
                 </a:solidFill>
                 <a:latin typeface="Calibri"/>
               </a:rPr>
-              <a:t>•  Follow up with Eddie on signing the amendment  —  Kate — reminder set 2026-09-24</a:t>
+              <a:t>•  Follow up with Eddie on signing the amendment  —  Kate — reminder re-set</a:t>
             </a:r>
           </a:p>
           <a:p>

</xml_diff>